<commit_message>
Preserve PPT placeholder formatting
</commit_message>
<xml_diff>
--- a/gsc-weekly-report/assets/weekly_template.pptx
+++ b/gsc-weekly-report/assets/weekly_template.pptx
@@ -3766,6 +3766,32 @@
             </a:endParaRPr>
           </a:p>
           <a:p>
+            <a:pPr marL="285750" fontAlgn="t">
+              <a:lnSpc>
+                <a:spcPct val="160000"/>
+              </a:lnSpc>
+            </a:pPr>
+            <a:r>
+              <a:rPr sz="1600">
+                <a:latin typeface="+mn-ea"/>
+              </a:rPr>
+              <a:t>{{MAIN_PROGRESS}}</a:t>
+            </a:r>
+          </a:p>
+          <a:p>
+            <a:pPr marL="285750" fontAlgn="t">
+              <a:lnSpc>
+                <a:spcPct val="160000"/>
+              </a:lnSpc>
+            </a:pPr>
+            <a:r>
+              <a:rPr sz="1600">
+                <a:latin typeface="+mn-ea"/>
+              </a:rPr>
+              <a:t/>
+            </a:r>
+          </a:p>
+          <a:p>
             <a:pPr marL="285750" indent="-285750" fontAlgn="t">
               <a:lnSpc>
                 <a:spcPct val="160000"/>
@@ -3777,11 +3803,24 @@
               <a:rPr sz="1600">
                 <a:latin typeface="+mn-ea"/>
               </a:rPr>
-              <a:t>{{MAIN_PROGRESS}}</a:t>
-            </a:r>
-          </a:p>
-          <a:p>
-            <a:pPr marL="285750" indent="-285750" fontAlgn="t">
+              <a:t>存在问题</a:t>
+            </a:r>
+          </a:p>
+          <a:p>
+            <a:pPr marL="285750" fontAlgn="t">
+              <a:lnSpc>
+                <a:spcPct val="160000"/>
+              </a:lnSpc>
+            </a:pPr>
+            <a:r>
+              <a:rPr sz="1600">
+                <a:latin typeface="+mn-ea"/>
+              </a:rPr>
+              <a:t>{{ISSUES}}</a:t>
+            </a:r>
+          </a:p>
+          <a:p>
+            <a:pPr marL="285750" fontAlgn="t">
               <a:lnSpc>
                 <a:spcPct val="160000"/>
               </a:lnSpc>
@@ -3805,7 +3844,33 @@
               <a:rPr sz="1600">
                 <a:latin typeface="+mn-ea"/>
               </a:rPr>
-              <a:t>存在问题</a:t>
+              <a:t>需要帮助</a:t>
+            </a:r>
+          </a:p>
+          <a:p>
+            <a:pPr marL="285750" fontAlgn="t">
+              <a:lnSpc>
+                <a:spcPct val="160000"/>
+              </a:lnSpc>
+            </a:pPr>
+            <a:r>
+              <a:rPr sz="1600">
+                <a:latin typeface="+mn-ea"/>
+              </a:rPr>
+              <a:t>{{HELP_NEEDED}}</a:t>
+            </a:r>
+          </a:p>
+          <a:p>
+            <a:pPr marL="285750" fontAlgn="t">
+              <a:lnSpc>
+                <a:spcPct val="160000"/>
+              </a:lnSpc>
+            </a:pPr>
+            <a:r>
+              <a:rPr sz="1600">
+                <a:latin typeface="+mn-ea"/>
+              </a:rPr>
+              <a:t/>
             </a:r>
           </a:p>
           <a:p>
@@ -3820,87 +3885,14 @@
               <a:rPr sz="1600">
                 <a:latin typeface="+mn-ea"/>
               </a:rPr>
-              <a:t>{{ISSUES}}</a:t>
-            </a:r>
-          </a:p>
-          <a:p>
-            <a:pPr marL="285750" indent="-285750" fontAlgn="t">
+              <a:t>下周计划</a:t>
+            </a:r>
+          </a:p>
+          <a:p>
+            <a:pPr marL="285750" fontAlgn="t">
               <a:lnSpc>
                 <a:spcPct val="160000"/>
               </a:lnSpc>
-            </a:pPr>
-            <a:r>
-              <a:rPr sz="1600">
-                <a:latin typeface="+mn-ea"/>
-              </a:rPr>
-              <a:t/>
-            </a:r>
-          </a:p>
-          <a:p>
-            <a:pPr marL="285750" indent="-285750" fontAlgn="t">
-              <a:lnSpc>
-                <a:spcPct val="160000"/>
-              </a:lnSpc>
-              <a:buFont typeface="Wingdings" panose="05000000000000000000" charset="0"/>
-              <a:buChar char=""/>
-            </a:pPr>
-            <a:r>
-              <a:rPr sz="1600">
-                <a:latin typeface="+mn-ea"/>
-              </a:rPr>
-              <a:t>需要帮助</a:t>
-            </a:r>
-          </a:p>
-          <a:p>
-            <a:pPr marL="285750" indent="-285750" fontAlgn="t">
-              <a:lnSpc>
-                <a:spcPct val="160000"/>
-              </a:lnSpc>
-              <a:buFont typeface="Wingdings" panose="05000000000000000000" charset="0"/>
-              <a:buChar char=""/>
-            </a:pPr>
-            <a:r>
-              <a:rPr sz="1600">
-                <a:latin typeface="+mn-ea"/>
-              </a:rPr>
-              <a:t>{{HELP_NEEDED}}</a:t>
-            </a:r>
-          </a:p>
-          <a:p>
-            <a:pPr marL="285750" indent="-285750" fontAlgn="t">
-              <a:lnSpc>
-                <a:spcPct val="160000"/>
-              </a:lnSpc>
-            </a:pPr>
-            <a:r>
-              <a:rPr sz="1600">
-                <a:latin typeface="+mn-ea"/>
-              </a:rPr>
-              <a:t/>
-            </a:r>
-          </a:p>
-          <a:p>
-            <a:pPr marL="285750" indent="-285750" fontAlgn="t">
-              <a:lnSpc>
-                <a:spcPct val="160000"/>
-              </a:lnSpc>
-              <a:buFont typeface="Wingdings" panose="05000000000000000000" charset="0"/>
-              <a:buChar char=""/>
-            </a:pPr>
-            <a:r>
-              <a:rPr sz="1600">
-                <a:latin typeface="+mn-ea"/>
-              </a:rPr>
-              <a:t>下周计划</a:t>
-            </a:r>
-          </a:p>
-          <a:p>
-            <a:pPr marL="285750" indent="-285750" fontAlgn="t">
-              <a:lnSpc>
-                <a:spcPct val="160000"/>
-              </a:lnSpc>
-              <a:buFont typeface="Wingdings" panose="05000000000000000000" charset="0"/>
-              <a:buChar char=""/>
             </a:pPr>
             <a:r>
               <a:rPr sz="1600">

</xml_diff>